<commit_message>
Fix firebase admin import path
</commit_message>
<xml_diff>
--- a/Soft Skills/Interview_Types_Visual_Workshop.pptx
+++ b/Soft Skills/Interview_Types_Visual_Workshop.pptx
@@ -5,19 +5,19 @@
     <p:sldMasterId id="2147483648" r:id="rId1"/>
   </p:sldMasterIdLst>
   <p:sldIdLst>
-    <p:sldId id="256" r:id="rId7"/>
-    <p:sldId id="257" r:id="rId8"/>
-    <p:sldId id="258" r:id="rId9"/>
-    <p:sldId id="259" r:id="rId10"/>
-    <p:sldId id="260" r:id="rId11"/>
-    <p:sldId id="261" r:id="rId12"/>
-    <p:sldId id="262" r:id="rId13"/>
-    <p:sldId id="263" r:id="rId14"/>
-    <p:sldId id="264" r:id="rId15"/>
-    <p:sldId id="265" r:id="rId16"/>
-    <p:sldId id="266" r:id="rId17"/>
-    <p:sldId id="267" r:id="rId18"/>
-    <p:sldId id="268" r:id="rId19"/>
+    <p:sldId id="256" r:id="rId2"/>
+    <p:sldId id="257" r:id="rId3"/>
+    <p:sldId id="258" r:id="rId4"/>
+    <p:sldId id="259" r:id="rId5"/>
+    <p:sldId id="260" r:id="rId6"/>
+    <p:sldId id="261" r:id="rId7"/>
+    <p:sldId id="262" r:id="rId8"/>
+    <p:sldId id="263" r:id="rId9"/>
+    <p:sldId id="264" r:id="rId10"/>
+    <p:sldId id="265" r:id="rId11"/>
+    <p:sldId id="266" r:id="rId12"/>
+    <p:sldId id="267" r:id="rId13"/>
+    <p:sldId id="268" r:id="rId14"/>
   </p:sldIdLst>
   <p:sldSz cx="9144000" cy="6858000" type="screen4x3"/>
   <p:notesSz cx="6858000" cy="9144000"/>
@@ -300,7 +300,8 @@
           <a:p>
             <a:fld id="{5BCAD085-E8A6-8845-BD4E-CB4CCA059FC4}" type="datetimeFigureOut">
               <a:rPr lang="en-US" smtClean="0"/>
-              <a:t>1/27/13</a:t>
+              <a:pPr/>
+              <a:t>8/11/2026</a:t>
             </a:fld>
             <a:endParaRPr lang="en-US"/>
           </a:p>
@@ -342,6 +343,7 @@
           <a:p>
             <a:fld id="{C1FF6DA9-008F-8B48-92A6-B652298478BF}" type="slidenum">
               <a:rPr lang="en-US" smtClean="0"/>
+              <a:pPr/>
               <a:t>‹#›</a:t>
             </a:fld>
             <a:endParaRPr lang="en-US"/>
@@ -351,7 +353,7 @@
     </p:spTree>
     <p:extLst>
       <p:ext uri="{BB962C8B-B14F-4D97-AF65-F5344CB8AC3E}">
-        <p14:creationId xmlns:p14="http://schemas.microsoft.com/office/powerpoint/2010/main" val="3168075583"/>
+        <p14:creationId xmlns:p14="http://schemas.microsoft.com/office/powerpoint/2010/main" xmlns="" val="3168075583"/>
       </p:ext>
     </p:extLst>
   </p:cSld>
@@ -470,7 +472,8 @@
           <a:p>
             <a:fld id="{5BCAD085-E8A6-8845-BD4E-CB4CCA059FC4}" type="datetimeFigureOut">
               <a:rPr lang="en-US" smtClean="0"/>
-              <a:t>1/27/13</a:t>
+              <a:pPr/>
+              <a:t>8/11/2026</a:t>
             </a:fld>
             <a:endParaRPr lang="en-US"/>
           </a:p>
@@ -512,6 +515,7 @@
           <a:p>
             <a:fld id="{C1FF6DA9-008F-8B48-92A6-B652298478BF}" type="slidenum">
               <a:rPr lang="en-US" smtClean="0"/>
+              <a:pPr/>
               <a:t>‹#›</a:t>
             </a:fld>
             <a:endParaRPr lang="en-US"/>
@@ -521,7 +525,7 @@
     </p:spTree>
     <p:extLst>
       <p:ext uri="{BB962C8B-B14F-4D97-AF65-F5344CB8AC3E}">
-        <p14:creationId xmlns:p14="http://schemas.microsoft.com/office/powerpoint/2010/main" val="2910927964"/>
+        <p14:creationId xmlns:p14="http://schemas.microsoft.com/office/powerpoint/2010/main" xmlns="" val="2910927964"/>
       </p:ext>
     </p:extLst>
   </p:cSld>
@@ -650,7 +654,8 @@
           <a:p>
             <a:fld id="{5BCAD085-E8A6-8845-BD4E-CB4CCA059FC4}" type="datetimeFigureOut">
               <a:rPr lang="en-US" smtClean="0"/>
-              <a:t>1/27/13</a:t>
+              <a:pPr/>
+              <a:t>8/11/2026</a:t>
             </a:fld>
             <a:endParaRPr lang="en-US"/>
           </a:p>
@@ -692,6 +697,7 @@
           <a:p>
             <a:fld id="{C1FF6DA9-008F-8B48-92A6-B652298478BF}" type="slidenum">
               <a:rPr lang="en-US" smtClean="0"/>
+              <a:pPr/>
               <a:t>‹#›</a:t>
             </a:fld>
             <a:endParaRPr lang="en-US"/>
@@ -701,7 +707,7 @@
     </p:spTree>
     <p:extLst>
       <p:ext uri="{BB962C8B-B14F-4D97-AF65-F5344CB8AC3E}">
-        <p14:creationId xmlns:p14="http://schemas.microsoft.com/office/powerpoint/2010/main" val="3612223792"/>
+        <p14:creationId xmlns:p14="http://schemas.microsoft.com/office/powerpoint/2010/main" xmlns="" val="3612223792"/>
       </p:ext>
     </p:extLst>
   </p:cSld>
@@ -820,7 +826,8 @@
           <a:p>
             <a:fld id="{5BCAD085-E8A6-8845-BD4E-CB4CCA059FC4}" type="datetimeFigureOut">
               <a:rPr lang="en-US" smtClean="0"/>
-              <a:t>1/27/13</a:t>
+              <a:pPr/>
+              <a:t>8/11/2026</a:t>
             </a:fld>
             <a:endParaRPr lang="en-US"/>
           </a:p>
@@ -862,6 +869,7 @@
           <a:p>
             <a:fld id="{C1FF6DA9-008F-8B48-92A6-B652298478BF}" type="slidenum">
               <a:rPr lang="en-US" smtClean="0"/>
+              <a:pPr/>
               <a:t>‹#›</a:t>
             </a:fld>
             <a:endParaRPr lang="en-US"/>
@@ -871,7 +879,7 @@
     </p:spTree>
     <p:extLst>
       <p:ext uri="{BB962C8B-B14F-4D97-AF65-F5344CB8AC3E}">
-        <p14:creationId xmlns:p14="http://schemas.microsoft.com/office/powerpoint/2010/main" val="2614314258"/>
+        <p14:creationId xmlns:p14="http://schemas.microsoft.com/office/powerpoint/2010/main" xmlns="" val="2614314258"/>
       </p:ext>
     </p:extLst>
   </p:cSld>
@@ -1066,7 +1074,8 @@
           <a:p>
             <a:fld id="{5BCAD085-E8A6-8845-BD4E-CB4CCA059FC4}" type="datetimeFigureOut">
               <a:rPr lang="en-US" smtClean="0"/>
-              <a:t>1/27/13</a:t>
+              <a:pPr/>
+              <a:t>8/11/2026</a:t>
             </a:fld>
             <a:endParaRPr lang="en-US"/>
           </a:p>
@@ -1108,6 +1117,7 @@
           <a:p>
             <a:fld id="{C1FF6DA9-008F-8B48-92A6-B652298478BF}" type="slidenum">
               <a:rPr lang="en-US" smtClean="0"/>
+              <a:pPr/>
               <a:t>‹#›</a:t>
             </a:fld>
             <a:endParaRPr lang="en-US"/>
@@ -1117,7 +1127,7 @@
     </p:spTree>
     <p:extLst>
       <p:ext uri="{BB962C8B-B14F-4D97-AF65-F5344CB8AC3E}">
-        <p14:creationId xmlns:p14="http://schemas.microsoft.com/office/powerpoint/2010/main" val="960648375"/>
+        <p14:creationId xmlns:p14="http://schemas.microsoft.com/office/powerpoint/2010/main" xmlns="" val="960648375"/>
       </p:ext>
     </p:extLst>
   </p:cSld>
@@ -1354,7 +1364,8 @@
           <a:p>
             <a:fld id="{5BCAD085-E8A6-8845-BD4E-CB4CCA059FC4}" type="datetimeFigureOut">
               <a:rPr lang="en-US" smtClean="0"/>
-              <a:t>1/27/13</a:t>
+              <a:pPr/>
+              <a:t>8/11/2026</a:t>
             </a:fld>
             <a:endParaRPr lang="en-US"/>
           </a:p>
@@ -1396,6 +1407,7 @@
           <a:p>
             <a:fld id="{C1FF6DA9-008F-8B48-92A6-B652298478BF}" type="slidenum">
               <a:rPr lang="en-US" smtClean="0"/>
+              <a:pPr/>
               <a:t>‹#›</a:t>
             </a:fld>
             <a:endParaRPr lang="en-US"/>
@@ -1405,7 +1417,7 @@
     </p:spTree>
     <p:extLst>
       <p:ext uri="{BB962C8B-B14F-4D97-AF65-F5344CB8AC3E}">
-        <p14:creationId xmlns:p14="http://schemas.microsoft.com/office/powerpoint/2010/main" val="2782244947"/>
+        <p14:creationId xmlns:p14="http://schemas.microsoft.com/office/powerpoint/2010/main" xmlns="" val="2782244947"/>
       </p:ext>
     </p:extLst>
   </p:cSld>
@@ -1776,7 +1788,8 @@
           <a:p>
             <a:fld id="{5BCAD085-E8A6-8845-BD4E-CB4CCA059FC4}" type="datetimeFigureOut">
               <a:rPr lang="en-US" smtClean="0"/>
-              <a:t>1/27/13</a:t>
+              <a:pPr/>
+              <a:t>8/11/2026</a:t>
             </a:fld>
             <a:endParaRPr lang="en-US"/>
           </a:p>
@@ -1818,6 +1831,7 @@
           <a:p>
             <a:fld id="{C1FF6DA9-008F-8B48-92A6-B652298478BF}" type="slidenum">
               <a:rPr lang="en-US" smtClean="0"/>
+              <a:pPr/>
               <a:t>‹#›</a:t>
             </a:fld>
             <a:endParaRPr lang="en-US"/>
@@ -1827,7 +1841,7 @@
     </p:spTree>
     <p:extLst>
       <p:ext uri="{BB962C8B-B14F-4D97-AF65-F5344CB8AC3E}">
-        <p14:creationId xmlns:p14="http://schemas.microsoft.com/office/powerpoint/2010/main" val="990158736"/>
+        <p14:creationId xmlns:p14="http://schemas.microsoft.com/office/powerpoint/2010/main" xmlns="" val="990158736"/>
       </p:ext>
     </p:extLst>
   </p:cSld>
@@ -1894,7 +1908,8 @@
           <a:p>
             <a:fld id="{5BCAD085-E8A6-8845-BD4E-CB4CCA059FC4}" type="datetimeFigureOut">
               <a:rPr lang="en-US" smtClean="0"/>
-              <a:t>1/27/13</a:t>
+              <a:pPr/>
+              <a:t>8/11/2026</a:t>
             </a:fld>
             <a:endParaRPr lang="en-US"/>
           </a:p>
@@ -1936,6 +1951,7 @@
           <a:p>
             <a:fld id="{C1FF6DA9-008F-8B48-92A6-B652298478BF}" type="slidenum">
               <a:rPr lang="en-US" smtClean="0"/>
+              <a:pPr/>
               <a:t>‹#›</a:t>
             </a:fld>
             <a:endParaRPr lang="en-US"/>
@@ -1945,7 +1961,7 @@
     </p:spTree>
     <p:extLst>
       <p:ext uri="{BB962C8B-B14F-4D97-AF65-F5344CB8AC3E}">
-        <p14:creationId xmlns:p14="http://schemas.microsoft.com/office/powerpoint/2010/main" val="727027711"/>
+        <p14:creationId xmlns:p14="http://schemas.microsoft.com/office/powerpoint/2010/main" xmlns="" val="727027711"/>
       </p:ext>
     </p:extLst>
   </p:cSld>
@@ -1989,7 +2005,8 @@
           <a:p>
             <a:fld id="{5BCAD085-E8A6-8845-BD4E-CB4CCA059FC4}" type="datetimeFigureOut">
               <a:rPr lang="en-US" smtClean="0"/>
-              <a:t>1/27/13</a:t>
+              <a:pPr/>
+              <a:t>8/11/2026</a:t>
             </a:fld>
             <a:endParaRPr lang="en-US"/>
           </a:p>
@@ -2031,6 +2048,7 @@
           <a:p>
             <a:fld id="{C1FF6DA9-008F-8B48-92A6-B652298478BF}" type="slidenum">
               <a:rPr lang="en-US" smtClean="0"/>
+              <a:pPr/>
               <a:t>‹#›</a:t>
             </a:fld>
             <a:endParaRPr lang="en-US"/>
@@ -2040,7 +2058,7 @@
     </p:spTree>
     <p:extLst>
       <p:ext uri="{BB962C8B-B14F-4D97-AF65-F5344CB8AC3E}">
-        <p14:creationId xmlns:p14="http://schemas.microsoft.com/office/powerpoint/2010/main" val="1212999818"/>
+        <p14:creationId xmlns:p14="http://schemas.microsoft.com/office/powerpoint/2010/main" xmlns="" val="1212999818"/>
       </p:ext>
     </p:extLst>
   </p:cSld>
@@ -2266,7 +2284,8 @@
           <a:p>
             <a:fld id="{5BCAD085-E8A6-8845-BD4E-CB4CCA059FC4}" type="datetimeFigureOut">
               <a:rPr lang="en-US" smtClean="0"/>
-              <a:t>1/27/13</a:t>
+              <a:pPr/>
+              <a:t>8/11/2026</a:t>
             </a:fld>
             <a:endParaRPr lang="en-US"/>
           </a:p>
@@ -2308,6 +2327,7 @@
           <a:p>
             <a:fld id="{C1FF6DA9-008F-8B48-92A6-B652298478BF}" type="slidenum">
               <a:rPr lang="en-US" smtClean="0"/>
+              <a:pPr/>
               <a:t>‹#›</a:t>
             </a:fld>
             <a:endParaRPr lang="en-US"/>
@@ -2317,7 +2337,7 @@
     </p:spTree>
     <p:extLst>
       <p:ext uri="{BB962C8B-B14F-4D97-AF65-F5344CB8AC3E}">
-        <p14:creationId xmlns:p14="http://schemas.microsoft.com/office/powerpoint/2010/main" val="1840726560"/>
+        <p14:creationId xmlns:p14="http://schemas.microsoft.com/office/powerpoint/2010/main" xmlns="" val="1840726560"/>
       </p:ext>
     </p:extLst>
   </p:cSld>
@@ -2519,7 +2539,8 @@
           <a:p>
             <a:fld id="{5BCAD085-E8A6-8845-BD4E-CB4CCA059FC4}" type="datetimeFigureOut">
               <a:rPr lang="en-US" smtClean="0"/>
-              <a:t>1/27/13</a:t>
+              <a:pPr/>
+              <a:t>8/11/2026</a:t>
             </a:fld>
             <a:endParaRPr lang="en-US"/>
           </a:p>
@@ -2561,6 +2582,7 @@
           <a:p>
             <a:fld id="{C1FF6DA9-008F-8B48-92A6-B652298478BF}" type="slidenum">
               <a:rPr lang="en-US" smtClean="0"/>
+              <a:pPr/>
               <a:t>‹#›</a:t>
             </a:fld>
             <a:endParaRPr lang="en-US"/>
@@ -2570,7 +2592,7 @@
     </p:spTree>
     <p:extLst>
       <p:ext uri="{BB962C8B-B14F-4D97-AF65-F5344CB8AC3E}">
-        <p14:creationId xmlns:p14="http://schemas.microsoft.com/office/powerpoint/2010/main" val="3889236939"/>
+        <p14:creationId xmlns:p14="http://schemas.microsoft.com/office/powerpoint/2010/main" xmlns="" val="3889236939"/>
       </p:ext>
     </p:extLst>
   </p:cSld>
@@ -2732,7 +2754,8 @@
           <a:p>
             <a:fld id="{5BCAD085-E8A6-8845-BD4E-CB4CCA059FC4}" type="datetimeFigureOut">
               <a:rPr lang="en-US" smtClean="0"/>
-              <a:t>1/27/13</a:t>
+              <a:pPr/>
+              <a:t>8/11/2026</a:t>
             </a:fld>
             <a:endParaRPr lang="en-US"/>
           </a:p>
@@ -2810,6 +2833,7 @@
           <a:p>
             <a:fld id="{C1FF6DA9-008F-8B48-92A6-B652298478BF}" type="slidenum">
               <a:rPr lang="en-US" smtClean="0"/>
+              <a:pPr/>
               <a:t>‹#›</a:t>
             </a:fld>
             <a:endParaRPr lang="en-US"/>
@@ -2819,7 +2843,7 @@
     </p:spTree>
     <p:extLst>
       <p:ext uri="{BB962C8B-B14F-4D97-AF65-F5344CB8AC3E}">
-        <p14:creationId xmlns:p14="http://schemas.microsoft.com/office/powerpoint/2010/main" val="2209977519"/>
+        <p14:creationId xmlns:p14="http://schemas.microsoft.com/office/powerpoint/2010/main" xmlns="" val="2209977519"/>
       </p:ext>
     </p:extLst>
   </p:cSld>
@@ -3091,7 +3115,7 @@
 </file>
 
 <file path=ppt/slides/slide1.xml><?xml version="1.0" encoding="utf-8"?>
-<p:sld xmlns:a="http://schemas.openxmlformats.org/drawingml/2006/main" xmlns:p="http://schemas.openxmlformats.org/presentationml/2006/main" xmlns:r="http://schemas.openxmlformats.org/officeDocument/2006/relationships">
+<p:sld xmlns:a="http://schemas.openxmlformats.org/drawingml/2006/main" xmlns:r="http://schemas.openxmlformats.org/officeDocument/2006/relationships" xmlns:p="http://schemas.openxmlformats.org/presentationml/2006/main">
   <p:cSld>
     <p:spTree>
       <p:nvGrpSpPr>
@@ -3099,7 +3123,14 @@
         <p:cNvGrpSpPr/>
         <p:nvPr/>
       </p:nvGrpSpPr>
-      <p:grpSpPr/>
+      <p:grpSpPr>
+        <a:xfrm>
+          <a:off x="0" y="0"/>
+          <a:ext cx="0" cy="0"/>
+          <a:chOff x="0" y="0"/>
+          <a:chExt cx="0" cy="0"/>
+        </a:xfrm>
+      </p:grpSpPr>
       <p:sp>
         <p:nvSpPr>
           <p:cNvPr id="2" name="Title 1"/>
@@ -3147,11 +3178,18 @@
   <p:clrMapOvr>
     <a:masterClrMapping/>
   </p:clrMapOvr>
+  <p:timing>
+    <p:tnLst>
+      <p:par>
+        <p:cTn id="1" dur="indefinite" restart="never" nodeType="tmRoot"/>
+      </p:par>
+    </p:tnLst>
+  </p:timing>
 </p:sld>
 </file>
 
 <file path=ppt/slides/slide10.xml><?xml version="1.0" encoding="utf-8"?>
-<p:sld xmlns:a="http://schemas.openxmlformats.org/drawingml/2006/main" xmlns:p="http://schemas.openxmlformats.org/presentationml/2006/main" xmlns:r="http://schemas.openxmlformats.org/officeDocument/2006/relationships">
+<p:sld xmlns:a="http://schemas.openxmlformats.org/drawingml/2006/main" xmlns:r="http://schemas.openxmlformats.org/officeDocument/2006/relationships" xmlns:p="http://schemas.openxmlformats.org/presentationml/2006/main">
   <p:cSld>
     <p:spTree>
       <p:nvGrpSpPr>
@@ -3159,7 +3197,14 @@
         <p:cNvGrpSpPr/>
         <p:nvPr/>
       </p:nvGrpSpPr>
-      <p:grpSpPr/>
+      <p:grpSpPr>
+        <a:xfrm>
+          <a:off x="0" y="0"/>
+          <a:ext cx="0" cy="0"/>
+          <a:chOff x="0" y="0"/>
+          <a:chExt cx="0" cy="0"/>
+        </a:xfrm>
+      </p:grpSpPr>
       <p:sp>
         <p:nvSpPr>
           <p:cNvPr id="2" name="Title 1"/>
@@ -3236,7 +3281,7 @@
 </file>
 
 <file path=ppt/slides/slide11.xml><?xml version="1.0" encoding="utf-8"?>
-<p:sld xmlns:a="http://schemas.openxmlformats.org/drawingml/2006/main" xmlns:p="http://schemas.openxmlformats.org/presentationml/2006/main" xmlns:r="http://schemas.openxmlformats.org/officeDocument/2006/relationships">
+<p:sld xmlns:a="http://schemas.openxmlformats.org/drawingml/2006/main" xmlns:r="http://schemas.openxmlformats.org/officeDocument/2006/relationships" xmlns:p="http://schemas.openxmlformats.org/presentationml/2006/main">
   <p:cSld>
     <p:spTree>
       <p:nvGrpSpPr>
@@ -3244,7 +3289,14 @@
         <p:cNvGrpSpPr/>
         <p:nvPr/>
       </p:nvGrpSpPr>
-      <p:grpSpPr/>
+      <p:grpSpPr>
+        <a:xfrm>
+          <a:off x="0" y="0"/>
+          <a:ext cx="0" cy="0"/>
+          <a:chOff x="0" y="0"/>
+          <a:chExt cx="0" cy="0"/>
+        </a:xfrm>
+      </p:grpSpPr>
       <p:sp>
         <p:nvSpPr>
           <p:cNvPr id="2" name="Title 1"/>
@@ -3326,7 +3378,7 @@
 </file>
 
 <file path=ppt/slides/slide12.xml><?xml version="1.0" encoding="utf-8"?>
-<p:sld xmlns:a="http://schemas.openxmlformats.org/drawingml/2006/main" xmlns:p="http://schemas.openxmlformats.org/presentationml/2006/main" xmlns:r="http://schemas.openxmlformats.org/officeDocument/2006/relationships">
+<p:sld xmlns:a="http://schemas.openxmlformats.org/drawingml/2006/main" xmlns:r="http://schemas.openxmlformats.org/officeDocument/2006/relationships" xmlns:p="http://schemas.openxmlformats.org/presentationml/2006/main">
   <p:cSld>
     <p:spTree>
       <p:nvGrpSpPr>
@@ -3334,7 +3386,14 @@
         <p:cNvGrpSpPr/>
         <p:nvPr/>
       </p:nvGrpSpPr>
-      <p:grpSpPr/>
+      <p:grpSpPr>
+        <a:xfrm>
+          <a:off x="0" y="0"/>
+          <a:ext cx="0" cy="0"/>
+          <a:chOff x="0" y="0"/>
+          <a:chExt cx="0" cy="0"/>
+        </a:xfrm>
+      </p:grpSpPr>
       <p:sp>
         <p:nvSpPr>
           <p:cNvPr id="2" name="Title 1"/>
@@ -3406,7 +3465,7 @@
 </file>
 
 <file path=ppt/slides/slide13.xml><?xml version="1.0" encoding="utf-8"?>
-<p:sld xmlns:a="http://schemas.openxmlformats.org/drawingml/2006/main" xmlns:p="http://schemas.openxmlformats.org/presentationml/2006/main" xmlns:r="http://schemas.openxmlformats.org/officeDocument/2006/relationships">
+<p:sld xmlns:a="http://schemas.openxmlformats.org/drawingml/2006/main" xmlns:r="http://schemas.openxmlformats.org/officeDocument/2006/relationships" xmlns:p="http://schemas.openxmlformats.org/presentationml/2006/main">
   <p:cSld>
     <p:spTree>
       <p:nvGrpSpPr>
@@ -3414,7 +3473,14 @@
         <p:cNvGrpSpPr/>
         <p:nvPr/>
       </p:nvGrpSpPr>
-      <p:grpSpPr/>
+      <p:grpSpPr>
+        <a:xfrm>
+          <a:off x="0" y="0"/>
+          <a:ext cx="0" cy="0"/>
+          <a:chOff x="0" y="0"/>
+          <a:chExt cx="0" cy="0"/>
+        </a:xfrm>
+      </p:grpSpPr>
       <p:sp>
         <p:nvSpPr>
           <p:cNvPr id="2" name="Title 1"/>
@@ -3481,7 +3547,7 @@
 </file>
 
 <file path=ppt/slides/slide2.xml><?xml version="1.0" encoding="utf-8"?>
-<p:sld xmlns:a="http://schemas.openxmlformats.org/drawingml/2006/main" xmlns:p="http://schemas.openxmlformats.org/presentationml/2006/main" xmlns:r="http://schemas.openxmlformats.org/officeDocument/2006/relationships">
+<p:sld xmlns:a="http://schemas.openxmlformats.org/drawingml/2006/main" xmlns:r="http://schemas.openxmlformats.org/officeDocument/2006/relationships" xmlns:p="http://schemas.openxmlformats.org/presentationml/2006/main">
   <p:cSld>
     <p:spTree>
       <p:nvGrpSpPr>
@@ -3489,7 +3555,14 @@
         <p:cNvGrpSpPr/>
         <p:nvPr/>
       </p:nvGrpSpPr>
-      <p:grpSpPr/>
+      <p:grpSpPr>
+        <a:xfrm>
+          <a:off x="0" y="0"/>
+          <a:ext cx="0" cy="0"/>
+          <a:chOff x="0" y="0"/>
+          <a:chExt cx="0" cy="0"/>
+        </a:xfrm>
+      </p:grpSpPr>
       <p:sp>
         <p:nvSpPr>
           <p:cNvPr id="2" name="Title 1"/>
@@ -3547,11 +3620,18 @@
   <p:clrMapOvr>
     <a:masterClrMapping/>
   </p:clrMapOvr>
+  <p:timing>
+    <p:tnLst>
+      <p:par>
+        <p:cTn id="1" dur="indefinite" restart="never" nodeType="tmRoot"/>
+      </p:par>
+    </p:tnLst>
+  </p:timing>
 </p:sld>
 </file>
 
 <file path=ppt/slides/slide3.xml><?xml version="1.0" encoding="utf-8"?>
-<p:sld xmlns:a="http://schemas.openxmlformats.org/drawingml/2006/main" xmlns:p="http://schemas.openxmlformats.org/presentationml/2006/main" xmlns:r="http://schemas.openxmlformats.org/officeDocument/2006/relationships">
+<p:sld xmlns:a="http://schemas.openxmlformats.org/drawingml/2006/main" xmlns:r="http://schemas.openxmlformats.org/officeDocument/2006/relationships" xmlns:p="http://schemas.openxmlformats.org/presentationml/2006/main">
   <p:cSld>
     <p:spTree>
       <p:nvGrpSpPr>
@@ -3559,7 +3639,14 @@
         <p:cNvGrpSpPr/>
         <p:nvPr/>
       </p:nvGrpSpPr>
-      <p:grpSpPr/>
+      <p:grpSpPr>
+        <a:xfrm>
+          <a:off x="0" y="0"/>
+          <a:ext cx="0" cy="0"/>
+          <a:chOff x="0" y="0"/>
+          <a:chExt cx="0" cy="0"/>
+        </a:xfrm>
+      </p:grpSpPr>
       <p:sp>
         <p:nvSpPr>
           <p:cNvPr id="2" name="Title 1"/>
@@ -3593,7 +3680,9 @@
         </p:nvSpPr>
         <p:spPr/>
         <p:txBody>
-          <a:bodyPr/>
+          <a:bodyPr>
+            <a:normAutofit lnSpcReduction="10000"/>
+          </a:bodyPr>
           <a:lstStyle/>
           <a:p>
             <a:r>
@@ -3637,11 +3726,18 @@
   <p:clrMapOvr>
     <a:masterClrMapping/>
   </p:clrMapOvr>
+  <p:timing>
+    <p:tnLst>
+      <p:par>
+        <p:cTn id="1" dur="indefinite" restart="never" nodeType="tmRoot"/>
+      </p:par>
+    </p:tnLst>
+  </p:timing>
 </p:sld>
 </file>
 
 <file path=ppt/slides/slide4.xml><?xml version="1.0" encoding="utf-8"?>
-<p:sld xmlns:a="http://schemas.openxmlformats.org/drawingml/2006/main" xmlns:p="http://schemas.openxmlformats.org/presentationml/2006/main" xmlns:r="http://schemas.openxmlformats.org/officeDocument/2006/relationships">
+<p:sld xmlns:a="http://schemas.openxmlformats.org/drawingml/2006/main" xmlns:r="http://schemas.openxmlformats.org/officeDocument/2006/relationships" xmlns:p="http://schemas.openxmlformats.org/presentationml/2006/main">
   <p:cSld>
     <p:spTree>
       <p:nvGrpSpPr>
@@ -3649,7 +3745,14 @@
         <p:cNvGrpSpPr/>
         <p:nvPr/>
       </p:nvGrpSpPr>
-      <p:grpSpPr/>
+      <p:grpSpPr>
+        <a:xfrm>
+          <a:off x="0" y="0"/>
+          <a:ext cx="0" cy="0"/>
+          <a:chOff x="0" y="0"/>
+          <a:chExt cx="0" cy="0"/>
+        </a:xfrm>
+      </p:grpSpPr>
       <p:sp>
         <p:nvSpPr>
           <p:cNvPr id="2" name="Title 1"/>
@@ -3666,7 +3769,20 @@
           <a:lstStyle/>
           <a:p>
             <a:r>
-              <a:t>🎤 Celebrity Interviews</a:t>
+              <a:rPr dirty="0"/>
+              <a:t>🎤 </a:t>
+            </a:r>
+            <a:r>
+              <a:rPr lang="en-IN" dirty="0" smtClean="0"/>
+              <a:t>    </a:t>
+            </a:r>
+            <a:r>
+              <a:rPr dirty="0" smtClean="0"/>
+              <a:t>Celebrity </a:t>
+            </a:r>
+            <a:r>
+              <a:rPr dirty="0"/>
+              <a:t>Interviews</a:t>
             </a:r>
           </a:p>
         </p:txBody>
@@ -3679,7 +3795,7 @@
         </p:nvSpPr>
         <p:spPr>
           <a:xfrm>
-            <a:off x="457200" y="1097280"/>
+            <a:off x="457200" y="2319641"/>
             <a:ext cx="3657600" cy="1828800"/>
           </a:xfrm>
           <a:prstGeom prst="roundRect">
@@ -3705,13 +3821,20 @@
           <a:lstStyle/>
           <a:p>
             <a:r>
+              <a:rPr dirty="0"/>
               <a:t>Goal</a:t>
             </a:r>
           </a:p>
           <a:p>
             <a:r>
-              <a:t>Entertainment &amp; relatability</a:t>
-            </a:r>
+              <a:rPr dirty="0"/>
+              <a:t>Entertainment &amp; </a:t>
+            </a:r>
+            <a:r>
+              <a:rPr dirty="0" err="1"/>
+              <a:t>relatability</a:t>
+            </a:r>
+            <a:endParaRPr dirty="0"/>
           </a:p>
         </p:txBody>
       </p:sp>
@@ -3723,7 +3846,7 @@
         </p:nvSpPr>
         <p:spPr>
           <a:xfrm>
-            <a:off x="4572000" y="1097280"/>
+            <a:off x="4572000" y="2319641"/>
             <a:ext cx="3657600" cy="1828800"/>
           </a:xfrm>
           <a:prstGeom prst="roundRect">
@@ -3767,7 +3890,7 @@
         </p:nvSpPr>
         <p:spPr>
           <a:xfrm>
-            <a:off x="2468880" y="2926080"/>
+            <a:off x="2468880" y="4894921"/>
             <a:ext cx="3657600" cy="914400"/>
           </a:xfrm>
           <a:prstGeom prst="chevron">
@@ -3807,7 +3930,7 @@
 </file>
 
 <file path=ppt/slides/slide5.xml><?xml version="1.0" encoding="utf-8"?>
-<p:sld xmlns:a="http://schemas.openxmlformats.org/drawingml/2006/main" xmlns:p="http://schemas.openxmlformats.org/presentationml/2006/main" xmlns:r="http://schemas.openxmlformats.org/officeDocument/2006/relationships">
+<p:sld xmlns:a="http://schemas.openxmlformats.org/drawingml/2006/main" xmlns:r="http://schemas.openxmlformats.org/officeDocument/2006/relationships" xmlns:p="http://schemas.openxmlformats.org/presentationml/2006/main">
   <p:cSld>
     <p:spTree>
       <p:nvGrpSpPr>
@@ -3815,7 +3938,14 @@
         <p:cNvGrpSpPr/>
         <p:nvPr/>
       </p:nvGrpSpPr>
-      <p:grpSpPr/>
+      <p:grpSpPr>
+        <a:xfrm>
+          <a:off x="0" y="0"/>
+          <a:ext cx="0" cy="0"/>
+          <a:chOff x="0" y="0"/>
+          <a:chExt cx="0" cy="0"/>
+        </a:xfrm>
+      </p:grpSpPr>
       <p:sp>
         <p:nvSpPr>
           <p:cNvPr id="2" name="Title 1"/>
@@ -3832,7 +3962,24 @@
           <a:lstStyle/>
           <a:p>
             <a:r>
-              <a:t>🏛️ Politician Interviews</a:t>
+              <a:rPr dirty="0" smtClean="0"/>
+              <a:t>🏛</a:t>
+            </a:r>
+            <a:r>
+              <a:rPr lang="en-IN" dirty="0" smtClean="0"/>
+              <a:t> </a:t>
+            </a:r>
+            <a:r>
+              <a:rPr lang="en-IN" dirty="0" smtClean="0"/>
+              <a:t>   </a:t>
+            </a:r>
+            <a:r>
+              <a:rPr dirty="0" smtClean="0"/>
+              <a:t>Politician </a:t>
+            </a:r>
+            <a:r>
+              <a:rPr dirty="0"/>
+              <a:t>Interviews</a:t>
             </a:r>
           </a:p>
         </p:txBody>
@@ -3845,7 +3992,7 @@
         </p:nvSpPr>
         <p:spPr>
           <a:xfrm>
-            <a:off x="457200" y="1097280"/>
+            <a:off x="457200" y="1815767"/>
             <a:ext cx="3657600" cy="1828800"/>
           </a:xfrm>
           <a:prstGeom prst="roundRect">
@@ -3889,7 +4036,7 @@
         </p:nvSpPr>
         <p:spPr>
           <a:xfrm>
-            <a:off x="4572000" y="1097280"/>
+            <a:off x="4572000" y="1815767"/>
             <a:ext cx="3657600" cy="1828800"/>
           </a:xfrm>
           <a:prstGeom prst="roundRect">
@@ -3933,7 +4080,7 @@
         </p:nvSpPr>
         <p:spPr>
           <a:xfrm>
-            <a:off x="2468880" y="2926080"/>
+            <a:off x="2468880" y="4428371"/>
             <a:ext cx="3657600" cy="914400"/>
           </a:xfrm>
           <a:prstGeom prst="chevron">
@@ -3973,7 +4120,7 @@
 </file>
 
 <file path=ppt/slides/slide6.xml><?xml version="1.0" encoding="utf-8"?>
-<p:sld xmlns:a="http://schemas.openxmlformats.org/drawingml/2006/main" xmlns:p="http://schemas.openxmlformats.org/presentationml/2006/main" xmlns:r="http://schemas.openxmlformats.org/officeDocument/2006/relationships">
+<p:sld xmlns:a="http://schemas.openxmlformats.org/drawingml/2006/main" xmlns:r="http://schemas.openxmlformats.org/officeDocument/2006/relationships" xmlns:p="http://schemas.openxmlformats.org/presentationml/2006/main">
   <p:cSld>
     <p:spTree>
       <p:nvGrpSpPr>
@@ -3981,7 +4128,14 @@
         <p:cNvGrpSpPr/>
         <p:nvPr/>
       </p:nvGrpSpPr>
-      <p:grpSpPr/>
+      <p:grpSpPr>
+        <a:xfrm>
+          <a:off x="0" y="0"/>
+          <a:ext cx="0" cy="0"/>
+          <a:chOff x="0" y="0"/>
+          <a:chExt cx="0" cy="0"/>
+        </a:xfrm>
+      </p:grpSpPr>
       <p:sp>
         <p:nvSpPr>
           <p:cNvPr id="2" name="Title 1"/>
@@ -3998,7 +4152,20 @@
           <a:lstStyle/>
           <a:p>
             <a:r>
-              <a:t>🏆 Topper Interviews</a:t>
+              <a:rPr dirty="0"/>
+              <a:t>🏆 </a:t>
+            </a:r>
+            <a:r>
+              <a:rPr lang="en-IN" dirty="0" smtClean="0"/>
+              <a:t>   </a:t>
+            </a:r>
+            <a:r>
+              <a:rPr dirty="0" smtClean="0"/>
+              <a:t>Topper </a:t>
+            </a:r>
+            <a:r>
+              <a:rPr dirty="0"/>
+              <a:t>Interviews</a:t>
             </a:r>
           </a:p>
         </p:txBody>
@@ -4011,7 +4178,7 @@
         </p:nvSpPr>
         <p:spPr>
           <a:xfrm>
-            <a:off x="457200" y="1097280"/>
+            <a:off x="457200" y="1871753"/>
             <a:ext cx="3657600" cy="1828800"/>
           </a:xfrm>
           <a:prstGeom prst="roundRect">
@@ -4055,7 +4222,7 @@
         </p:nvSpPr>
         <p:spPr>
           <a:xfrm>
-            <a:off x="4572000" y="1097280"/>
+            <a:off x="4572000" y="1871753"/>
             <a:ext cx="3657600" cy="1828800"/>
           </a:xfrm>
           <a:prstGeom prst="roundRect">
@@ -4081,11 +4248,13 @@
           <a:lstStyle/>
           <a:p>
             <a:r>
+              <a:rPr dirty="0"/>
               <a:t>Rewards</a:t>
             </a:r>
           </a:p>
           <a:p>
             <a:r>
+              <a:rPr dirty="0"/>
               <a:t>Structure, discipline, humility</a:t>
             </a:r>
           </a:p>
@@ -4099,7 +4268,7 @@
         </p:nvSpPr>
         <p:spPr>
           <a:xfrm>
-            <a:off x="2468880" y="2926080"/>
+            <a:off x="2468880" y="4372385"/>
             <a:ext cx="3657600" cy="914400"/>
           </a:xfrm>
           <a:prstGeom prst="chevron">
@@ -4139,7 +4308,7 @@
 </file>
 
 <file path=ppt/slides/slide7.xml><?xml version="1.0" encoding="utf-8"?>
-<p:sld xmlns:a="http://schemas.openxmlformats.org/drawingml/2006/main" xmlns:p="http://schemas.openxmlformats.org/presentationml/2006/main" xmlns:r="http://schemas.openxmlformats.org/officeDocument/2006/relationships">
+<p:sld xmlns:a="http://schemas.openxmlformats.org/drawingml/2006/main" xmlns:r="http://schemas.openxmlformats.org/officeDocument/2006/relationships" xmlns:p="http://schemas.openxmlformats.org/presentationml/2006/main">
   <p:cSld>
     <p:spTree>
       <p:nvGrpSpPr>
@@ -4147,7 +4316,14 @@
         <p:cNvGrpSpPr/>
         <p:nvPr/>
       </p:nvGrpSpPr>
-      <p:grpSpPr/>
+      <p:grpSpPr>
+        <a:xfrm>
+          <a:off x="0" y="0"/>
+          <a:ext cx="0" cy="0"/>
+          <a:chOff x="0" y="0"/>
+          <a:chExt cx="0" cy="0"/>
+        </a:xfrm>
+      </p:grpSpPr>
       <p:sp>
         <p:nvSpPr>
           <p:cNvPr id="2" name="Title 1"/>
@@ -4164,7 +4340,20 @@
           <a:lstStyle/>
           <a:p>
             <a:r>
-              <a:t>🎓 College Admission Interviews</a:t>
+              <a:rPr dirty="0"/>
+              <a:t>🎓 </a:t>
+            </a:r>
+            <a:r>
+              <a:rPr lang="en-IN" dirty="0" smtClean="0"/>
+              <a:t>    </a:t>
+            </a:r>
+            <a:r>
+              <a:rPr dirty="0" smtClean="0"/>
+              <a:t>College </a:t>
+            </a:r>
+            <a:r>
+              <a:rPr dirty="0"/>
+              <a:t>Admission Interviews</a:t>
             </a:r>
           </a:p>
         </p:txBody>
@@ -4177,7 +4366,7 @@
         </p:nvSpPr>
         <p:spPr>
           <a:xfrm>
-            <a:off x="457200" y="1097280"/>
+            <a:off x="671813" y="1675802"/>
             <a:ext cx="3657600" cy="1828800"/>
           </a:xfrm>
           <a:prstGeom prst="roundRect">
@@ -4221,7 +4410,7 @@
         </p:nvSpPr>
         <p:spPr>
           <a:xfrm>
-            <a:off x="4572000" y="1097280"/>
+            <a:off x="4786613" y="1675802"/>
             <a:ext cx="3657600" cy="1828800"/>
           </a:xfrm>
           <a:prstGeom prst="roundRect">
@@ -4265,7 +4454,7 @@
         </p:nvSpPr>
         <p:spPr>
           <a:xfrm>
-            <a:off x="2468880" y="2926080"/>
+            <a:off x="2683493" y="4241751"/>
             <a:ext cx="3657600" cy="914400"/>
           </a:xfrm>
           <a:prstGeom prst="chevron">
@@ -4291,6 +4480,7 @@
           <a:lstStyle/>
           <a:p>
             <a:r>
+              <a:rPr dirty="0"/>
               <a:t>Hidden Skill: Thoughtful opinions</a:t>
             </a:r>
           </a:p>
@@ -4305,7 +4495,7 @@
 </file>
 
 <file path=ppt/slides/slide8.xml><?xml version="1.0" encoding="utf-8"?>
-<p:sld xmlns:a="http://schemas.openxmlformats.org/drawingml/2006/main" xmlns:p="http://schemas.openxmlformats.org/presentationml/2006/main" xmlns:r="http://schemas.openxmlformats.org/officeDocument/2006/relationships">
+<p:sld xmlns:a="http://schemas.openxmlformats.org/drawingml/2006/main" xmlns:r="http://schemas.openxmlformats.org/officeDocument/2006/relationships" xmlns:p="http://schemas.openxmlformats.org/presentationml/2006/main">
   <p:cSld>
     <p:spTree>
       <p:nvGrpSpPr>
@@ -4313,7 +4503,14 @@
         <p:cNvGrpSpPr/>
         <p:nvPr/>
       </p:nvGrpSpPr>
-      <p:grpSpPr/>
+      <p:grpSpPr>
+        <a:xfrm>
+          <a:off x="0" y="0"/>
+          <a:ext cx="0" cy="0"/>
+          <a:chOff x="0" y="0"/>
+          <a:chExt cx="0" cy="0"/>
+        </a:xfrm>
+      </p:grpSpPr>
       <p:sp>
         <p:nvSpPr>
           <p:cNvPr id="2" name="Title 1"/>
@@ -4330,6 +4527,7 @@
           <a:lstStyle/>
           <a:p>
             <a:r>
+              <a:rPr dirty="0"/>
               <a:t>⚖️ UPSC / IAS Interviews</a:t>
             </a:r>
           </a:p>
@@ -4343,7 +4541,7 @@
         </p:nvSpPr>
         <p:spPr>
           <a:xfrm>
-            <a:off x="457200" y="1097280"/>
+            <a:off x="457200" y="1778443"/>
             <a:ext cx="3657600" cy="1828800"/>
           </a:xfrm>
           <a:prstGeom prst="roundRect">
@@ -4369,13 +4567,20 @@
           <a:lstStyle/>
           <a:p>
             <a:r>
+              <a:rPr dirty="0"/>
               <a:t>Goal</a:t>
             </a:r>
           </a:p>
           <a:p>
             <a:r>
-              <a:t>Temperament &amp; judgement</a:t>
-            </a:r>
+              <a:rPr dirty="0"/>
+              <a:t>Temperament &amp; </a:t>
+            </a:r>
+            <a:r>
+              <a:rPr dirty="0" err="1"/>
+              <a:t>judgement</a:t>
+            </a:r>
+            <a:endParaRPr dirty="0"/>
           </a:p>
         </p:txBody>
       </p:sp>
@@ -4387,7 +4592,7 @@
         </p:nvSpPr>
         <p:spPr>
           <a:xfrm>
-            <a:off x="4572000" y="1097280"/>
+            <a:off x="4572000" y="1778443"/>
             <a:ext cx="3657600" cy="1828800"/>
           </a:xfrm>
           <a:prstGeom prst="roundRect">
@@ -4413,11 +4618,13 @@
           <a:lstStyle/>
           <a:p>
             <a:r>
+              <a:rPr dirty="0"/>
               <a:t>Rewards</a:t>
             </a:r>
           </a:p>
           <a:p>
             <a:r>
+              <a:rPr dirty="0"/>
               <a:t>Balance, ethics, calm thinking</a:t>
             </a:r>
           </a:p>
@@ -4431,7 +4638,7 @@
         </p:nvSpPr>
         <p:spPr>
           <a:xfrm>
-            <a:off x="2468880" y="2926080"/>
+            <a:off x="2468880" y="4195096"/>
             <a:ext cx="3657600" cy="914400"/>
           </a:xfrm>
           <a:prstGeom prst="chevron">
@@ -4457,6 +4664,7 @@
           <a:lstStyle/>
           <a:p>
             <a:r>
+              <a:rPr dirty="0"/>
               <a:t>Hidden Skill: Reasoning under uncertainty</a:t>
             </a:r>
           </a:p>
@@ -4471,7 +4679,7 @@
 </file>
 
 <file path=ppt/slides/slide9.xml><?xml version="1.0" encoding="utf-8"?>
-<p:sld xmlns:a="http://schemas.openxmlformats.org/drawingml/2006/main" xmlns:p="http://schemas.openxmlformats.org/presentationml/2006/main" xmlns:r="http://schemas.openxmlformats.org/officeDocument/2006/relationships">
+<p:sld xmlns:a="http://schemas.openxmlformats.org/drawingml/2006/main" xmlns:r="http://schemas.openxmlformats.org/officeDocument/2006/relationships" xmlns:p="http://schemas.openxmlformats.org/presentationml/2006/main">
   <p:cSld>
     <p:spTree>
       <p:nvGrpSpPr>
@@ -4479,7 +4687,14 @@
         <p:cNvGrpSpPr/>
         <p:nvPr/>
       </p:nvGrpSpPr>
-      <p:grpSpPr/>
+      <p:grpSpPr>
+        <a:xfrm>
+          <a:off x="0" y="0"/>
+          <a:ext cx="0" cy="0"/>
+          <a:chOff x="0" y="0"/>
+          <a:chExt cx="0" cy="0"/>
+        </a:xfrm>
+      </p:grpSpPr>
       <p:sp>
         <p:nvSpPr>
           <p:cNvPr id="2" name="Title 1"/>
@@ -4496,7 +4711,20 @@
           <a:lstStyle/>
           <a:p>
             <a:r>
-              <a:t>💼 Company Hiring Interviews</a:t>
+              <a:rPr dirty="0"/>
+              <a:t>💼 </a:t>
+            </a:r>
+            <a:r>
+              <a:rPr lang="en-IN" dirty="0" smtClean="0"/>
+              <a:t>     </a:t>
+            </a:r>
+            <a:r>
+              <a:rPr dirty="0" smtClean="0"/>
+              <a:t>Company </a:t>
+            </a:r>
+            <a:r>
+              <a:rPr dirty="0"/>
+              <a:t>Hiring Interviews</a:t>
             </a:r>
           </a:p>
         </p:txBody>
@@ -4509,7 +4737,7 @@
         </p:nvSpPr>
         <p:spPr>
           <a:xfrm>
-            <a:off x="457200" y="1097280"/>
+            <a:off x="457200" y="1741119"/>
             <a:ext cx="3657600" cy="1828800"/>
           </a:xfrm>
           <a:prstGeom prst="roundRect">
@@ -4553,7 +4781,7 @@
         </p:nvSpPr>
         <p:spPr>
           <a:xfrm>
-            <a:off x="4572000" y="1097280"/>
+            <a:off x="4572000" y="1741119"/>
             <a:ext cx="3657600" cy="1828800"/>
           </a:xfrm>
           <a:prstGeom prst="roundRect">
@@ -4597,7 +4825,7 @@
         </p:nvSpPr>
         <p:spPr>
           <a:xfrm>
-            <a:off x="2468880" y="2926080"/>
+            <a:off x="2468880" y="4325730"/>
             <a:ext cx="3657600" cy="914400"/>
           </a:xfrm>
           <a:prstGeom prst="chevron">

</xml_diff>